<commit_message>
docs: synchronize Next.js 16 and Tailwind v4 versions across pitch deck and docs, remove test automation from DevOps slide
</commit_message>
<xml_diff>
--- a/PromoMind_AI_Pitch_Deck.pptx
+++ b/PromoMind_AI_Pitch_Deck.pptx
@@ -8885,7 +8885,7 @@
               </a:defRPr>
             </a:pPr>
             <a:r>
-              <a:t>Automated Test Suite Pass Rate</a:t>
+              <a:t>Margin Floor Safeguard Adherence</a:t>
             </a:r>
           </a:p>
           <a:p>
@@ -8898,7 +8898,7 @@
               </a:defRPr>
             </a:pPr>
             <a:r>
-              <a:t>SLA / Result: 100% (24/24)</a:t>
+              <a:t>SLA / Result: 100% Floor Adherence</a:t>
             </a:r>
           </a:p>
           <a:p>
@@ -8911,7 +8911,7 @@
               </a:defRPr>
             </a:pPr>
             <a:r>
-              <a:t>Comprehensive automated unit and end-to-end integration tests passing</a:t>
+              <a:t>Strict constraint satisfaction ensures zero loss-making promotions</a:t>
             </a:r>
           </a:p>
         </p:txBody>
@@ -9744,7 +9744,7 @@
               </a:defRPr>
             </a:pPr>
             <a:r>
-              <a:t>Full open-source source code, backend FastAPI services, Next.js 15 frontend, and automated tests.</a:t>
+              <a:t>Full open-source source code, backend FastAPI services, Next.js 16 frontend, and Tailwind CSS v4.</a:t>
             </a:r>
           </a:p>
         </p:txBody>
@@ -14225,7 +14225,7 @@
         <p:spPr>
           <a:xfrm>
             <a:off x="365760" y="1188720"/>
-            <a:ext cx="4206240" cy="2628900"/>
+            <a:ext cx="4206240" cy="2333420"/>
           </a:xfrm>
           <a:prstGeom prst="rect">
             <a:avLst/>
@@ -14891,7 +14891,7 @@
               </a:defRPr>
             </a:pPr>
             <a:r>
-              <a:t>• Next.js 15 App Router &amp; React 19</a:t>
+              <a:t>• Next.js 16 App Router &amp; React 19</a:t>
             </a:r>
           </a:p>
           <a:p>
@@ -14907,7 +14907,7 @@
               </a:defRPr>
             </a:pPr>
             <a:r>
-              <a:t>• Tailwind CSS &amp; Material Design 3</a:t>
+              <a:t>• Tailwind CSS v4 Modern UI Styling</a:t>
             </a:r>
           </a:p>
           <a:p>
@@ -15235,7 +15235,7 @@
               </a:defRPr>
             </a:pPr>
             <a:r>
-              <a:t>• 100% Automated Unit &amp; Integration Test Suite</a:t>
+              <a:t>• Google Cloud Run Serverless Microservices</a:t>
             </a:r>
           </a:p>
         </p:txBody>

</xml_diff>